<commit_message>
Configure root static deployment for Vercel, ignore backend files, and sync presentation
</commit_message>
<xml_diff>
--- a/Student_Placement_and_Internship_Management_System_Presentation.pptx
+++ b/Student_Placement_and_Internship_Management_System_Presentation.pptx
@@ -163,63 +163,10 @@
   <pc:docChgLst>
     <pc:chgData name="thallapakasritanavi@gmail.com" userId="ca8b25171f1ef2f4" providerId="LiveId" clId="{B39BC8E7-EAD7-45E4-ABEA-2371A8641612}"/>
     <pc:docChg chg="undo custSel modSld">
-      <pc:chgData name="thallapakasritanavi@gmail.com" userId="ca8b25171f1ef2f4" providerId="LiveId" clId="{B39BC8E7-EAD7-45E4-ABEA-2371A8641612}" dt="2026-10-17T03:07:50.544" v="873" actId="255"/>
+      <pc:chgData name="thallapakasritanavi@gmail.com" userId="ca8b25171f1ef2f4" providerId="LiveId" clId="{B39BC8E7-EAD7-45E4-ABEA-2371A8641612}" dt="2026-10-24T13:24:44.135" v="874" actId="1036"/>
       <pc:docMkLst>
         <pc:docMk/>
       </pc:docMkLst>
-      <pc:sldChg chg="modSp mod">
-        <pc:chgData name="thallapakasritanavi@gmail.com" userId="ca8b25171f1ef2f4" providerId="LiveId" clId="{B39BC8E7-EAD7-45E4-ABEA-2371A8641612}" dt="2026-09-23T02:40:05.073" v="868" actId="255"/>
-        <pc:sldMkLst>
-          <pc:docMk/>
-          <pc:sldMk cId="0" sldId="256"/>
-        </pc:sldMkLst>
-        <pc:spChg chg="mod">
-          <ac:chgData name="thallapakasritanavi@gmail.com" userId="ca8b25171f1ef2f4" providerId="LiveId" clId="{B39BC8E7-EAD7-45E4-ABEA-2371A8641612}" dt="2026-09-22T00:56:55.635" v="6" actId="207"/>
-          <ac:spMkLst>
-            <pc:docMk/>
-            <pc:sldMk cId="0" sldId="256"/>
-            <ac:spMk id="17" creationId="{00000000-0000-0000-0000-000000000000}"/>
-          </ac:spMkLst>
-        </pc:spChg>
-        <pc:spChg chg="mod">
-          <ac:chgData name="thallapakasritanavi@gmail.com" userId="ca8b25171f1ef2f4" providerId="LiveId" clId="{B39BC8E7-EAD7-45E4-ABEA-2371A8641612}" dt="2026-09-23T02:40:05.073" v="868" actId="255"/>
-          <ac:spMkLst>
-            <pc:docMk/>
-            <pc:sldMk cId="0" sldId="256"/>
-            <ac:spMk id="29" creationId="{431E86DB-7CEA-B3DC-1DF2-33457A550B1A}"/>
-          </ac:spMkLst>
-        </pc:spChg>
-      </pc:sldChg>
-      <pc:sldChg chg="modSp mod">
-        <pc:chgData name="thallapakasritanavi@gmail.com" userId="ca8b25171f1ef2f4" providerId="LiveId" clId="{B39BC8E7-EAD7-45E4-ABEA-2371A8641612}" dt="2026-09-22T01:01:03.971" v="51" actId="27636"/>
-        <pc:sldMkLst>
-          <pc:docMk/>
-          <pc:sldMk cId="3440899806" sldId="257"/>
-        </pc:sldMkLst>
-        <pc:spChg chg="mod">
-          <ac:chgData name="thallapakasritanavi@gmail.com" userId="ca8b25171f1ef2f4" providerId="LiveId" clId="{B39BC8E7-EAD7-45E4-ABEA-2371A8641612}" dt="2026-09-22T01:01:03.971" v="51" actId="27636"/>
-          <ac:spMkLst>
-            <pc:docMk/>
-            <pc:sldMk cId="3440899806" sldId="257"/>
-            <ac:spMk id="3" creationId="{00000000-0000-0000-0000-000000000000}"/>
-          </ac:spMkLst>
-        </pc:spChg>
-      </pc:sldChg>
-      <pc:sldChg chg="modSp mod">
-        <pc:chgData name="thallapakasritanavi@gmail.com" userId="ca8b25171f1ef2f4" providerId="LiveId" clId="{B39BC8E7-EAD7-45E4-ABEA-2371A8641612}" dt="2026-09-22T01:06:23.062" v="547" actId="5793"/>
-        <pc:sldMkLst>
-          <pc:docMk/>
-          <pc:sldMk cId="4270359157" sldId="258"/>
-        </pc:sldMkLst>
-        <pc:spChg chg="mod">
-          <ac:chgData name="thallapakasritanavi@gmail.com" userId="ca8b25171f1ef2f4" providerId="LiveId" clId="{B39BC8E7-EAD7-45E4-ABEA-2371A8641612}" dt="2026-09-22T01:06:23.062" v="547" actId="5793"/>
-          <ac:spMkLst>
-            <pc:docMk/>
-            <pc:sldMk cId="4270359157" sldId="258"/>
-            <ac:spMk id="4" creationId="{00000000-0000-0000-0000-000000000000}"/>
-          </ac:spMkLst>
-        </pc:spChg>
-      </pc:sldChg>
       <pc:sldChg chg="modSp mod">
         <pc:chgData name="thallapakasritanavi@gmail.com" userId="ca8b25171f1ef2f4" providerId="LiveId" clId="{B39BC8E7-EAD7-45E4-ABEA-2371A8641612}" dt="2026-10-17T03:07:50.544" v="873" actId="255"/>
         <pc:sldMkLst>
@@ -236,21 +183,6 @@
         </pc:spChg>
       </pc:sldChg>
       <pc:sldChg chg="modSp mod">
-        <pc:chgData name="thallapakasritanavi@gmail.com" userId="ca8b25171f1ef2f4" providerId="LiveId" clId="{B39BC8E7-EAD7-45E4-ABEA-2371A8641612}" dt="2026-09-22T01:12:22.284" v="573" actId="255"/>
-        <pc:sldMkLst>
-          <pc:docMk/>
-          <pc:sldMk cId="0" sldId="261"/>
-        </pc:sldMkLst>
-        <pc:spChg chg="mod">
-          <ac:chgData name="thallapakasritanavi@gmail.com" userId="ca8b25171f1ef2f4" providerId="LiveId" clId="{B39BC8E7-EAD7-45E4-ABEA-2371A8641612}" dt="2026-09-22T01:12:22.284" v="573" actId="255"/>
-          <ac:spMkLst>
-            <pc:docMk/>
-            <pc:sldMk cId="0" sldId="261"/>
-            <ac:spMk id="3" creationId="{00000000-0000-0000-0000-000000000000}"/>
-          </ac:spMkLst>
-        </pc:spChg>
-      </pc:sldChg>
-      <pc:sldChg chg="modSp mod">
         <pc:chgData name="thallapakasritanavi@gmail.com" userId="ca8b25171f1ef2f4" providerId="LiveId" clId="{B39BC8E7-EAD7-45E4-ABEA-2371A8641612}" dt="2026-10-17T03:05:42.112" v="869" actId="20577"/>
         <pc:sldMkLst>
           <pc:docMk/>
@@ -261,6 +193,21 @@
           <ac:spMkLst>
             <pc:docMk/>
             <pc:sldMk cId="0" sldId="262"/>
+            <ac:spMk id="3" creationId="{00000000-0000-0000-0000-000000000000}"/>
+          </ac:spMkLst>
+        </pc:spChg>
+      </pc:sldChg>
+      <pc:sldChg chg="modSp mod">
+        <pc:chgData name="thallapakasritanavi@gmail.com" userId="ca8b25171f1ef2f4" providerId="LiveId" clId="{B39BC8E7-EAD7-45E4-ABEA-2371A8641612}" dt="2026-10-24T13:24:44.135" v="874" actId="1036"/>
+        <pc:sldMkLst>
+          <pc:docMk/>
+          <pc:sldMk cId="0" sldId="263"/>
+        </pc:sldMkLst>
+        <pc:spChg chg="mod">
+          <ac:chgData name="thallapakasritanavi@gmail.com" userId="ca8b25171f1ef2f4" providerId="LiveId" clId="{B39BC8E7-EAD7-45E4-ABEA-2371A8641612}" dt="2026-10-24T13:24:44.135" v="874" actId="1036"/>
+          <ac:spMkLst>
+            <pc:docMk/>
+            <pc:sldMk cId="0" sldId="263"/>
             <ac:spMk id="3" creationId="{00000000-0000-0000-0000-000000000000}"/>
           </ac:spMkLst>
         </pc:spChg>
@@ -353,7 +300,7 @@
             <a:fld id="{D5F44B48-72A2-4A15-9A9B-0DA2BF7C6B02}" type="datetimeFigureOut">
               <a:rPr lang="en-US" smtClean="0"/>
               <a:pPr/>
-              <a:t>10/17/2026</a:t>
+              <a:t>10/24/2026</a:t>
             </a:fld>
             <a:endParaRPr lang="en-US"/>
           </a:p>
@@ -972,7 +919,7 @@
           <a:p>
             <a:fld id="{B3BD94B3-44B9-44B7-85A7-F056FA607D46}" type="datetime3">
               <a:rPr lang="en-US" smtClean="0"/>
-              <a:t>17 October 2026</a:t>
+              <a:t>24 October 2026</a:t>
             </a:fld>
             <a:endParaRPr lang="en-US"/>
           </a:p>
@@ -1144,7 +1091,7 @@
           <a:p>
             <a:fld id="{C6B910C5-081D-4FA6-9B78-BB56BEB475DD}" type="datetime3">
               <a:rPr lang="en-US" smtClean="0"/>
-              <a:t>17 October 2026</a:t>
+              <a:t>24 October 2026</a:t>
             </a:fld>
             <a:endParaRPr lang="en-US"/>
           </a:p>
@@ -1326,7 +1273,7 @@
           <a:p>
             <a:fld id="{418360AF-72BE-4445-B200-736511B20555}" type="datetime3">
               <a:rPr lang="en-US" smtClean="0"/>
-              <a:t>17 October 2026</a:t>
+              <a:t>24 October 2026</a:t>
             </a:fld>
             <a:endParaRPr lang="en-US"/>
           </a:p>
@@ -1504,7 +1451,7 @@
           <a:p>
             <a:fld id="{10B6530B-5C68-4965-B8A9-8C18D26903BD}" type="datetime3">
               <a:rPr lang="en-US" smtClean="0"/>
-              <a:t>17 October 2026</a:t>
+              <a:t>24 October 2026</a:t>
             </a:fld>
             <a:endParaRPr lang="en-US" dirty="0"/>
           </a:p>
@@ -1692,7 +1639,7 @@
           <a:p>
             <a:fld id="{EB7275DB-6D13-480B-AC77-F5019BDC5287}" type="datetime3">
               <a:rPr lang="en-US" smtClean="0"/>
-              <a:t>17 October 2026</a:t>
+              <a:t>24 October 2026</a:t>
             </a:fld>
             <a:endParaRPr lang="en-US"/>
           </a:p>
@@ -1941,7 +1888,7 @@
           <a:p>
             <a:fld id="{9B2A365F-315E-4D26-B736-3944439F5E09}" type="datetime3">
               <a:rPr lang="en-US" smtClean="0"/>
-              <a:t>17 October 2026</a:t>
+              <a:t>24 October 2026</a:t>
             </a:fld>
             <a:endParaRPr lang="en-US"/>
           </a:p>
@@ -2230,7 +2177,7 @@
           <a:p>
             <a:fld id="{9AB1E7AE-CF1A-4AE7-BD2C-F950D278A3DB}" type="datetime3">
               <a:rPr lang="en-US" smtClean="0"/>
-              <a:t>17 October 2026</a:t>
+              <a:t>24 October 2026</a:t>
             </a:fld>
             <a:endParaRPr lang="en-US"/>
           </a:p>
@@ -2653,7 +2600,7 @@
           <a:p>
             <a:fld id="{2C6D51F8-804C-441D-85CA-D64DC6F78406}" type="datetime3">
               <a:rPr lang="en-US" smtClean="0"/>
-              <a:t>17 October 2026</a:t>
+              <a:t>24 October 2026</a:t>
             </a:fld>
             <a:endParaRPr lang="en-US"/>
           </a:p>
@@ -2774,7 +2721,7 @@
           <a:p>
             <a:fld id="{B97CCCDB-4457-4C48-985F-BD1C33DF88D2}" type="datetime3">
               <a:rPr lang="en-US" smtClean="0"/>
-              <a:t>17 October 2026</a:t>
+              <a:t>24 October 2026</a:t>
             </a:fld>
             <a:endParaRPr lang="en-US"/>
           </a:p>
@@ -2873,7 +2820,7 @@
           <a:p>
             <a:fld id="{C3F4AF7E-7813-4879-8B55-5575B0080D39}" type="datetime3">
               <a:rPr lang="en-US" smtClean="0"/>
-              <a:t>17 October 2026</a:t>
+              <a:t>24 October 2026</a:t>
             </a:fld>
             <a:endParaRPr lang="en-US"/>
           </a:p>
@@ -3152,7 +3099,7 @@
           <a:p>
             <a:fld id="{19EC94D0-F97F-48E4-A142-9DA614267486}" type="datetime3">
               <a:rPr lang="en-US" smtClean="0"/>
-              <a:t>17 October 2026</a:t>
+              <a:t>24 October 2026</a:t>
             </a:fld>
             <a:endParaRPr lang="en-US"/>
           </a:p>
@@ -3408,7 +3355,7 @@
           <a:p>
             <a:fld id="{557DA9B2-FBCA-4233-9590-C0754509BDB5}" type="datetime3">
               <a:rPr lang="en-US" smtClean="0"/>
-              <a:t>17 October 2026</a:t>
+              <a:t>24 October 2026</a:t>
             </a:fld>
             <a:endParaRPr lang="en-US"/>
           </a:p>
@@ -3623,7 +3570,7 @@
           <a:p>
             <a:fld id="{484D4881-3C1B-4E10-8E47-87CE42F43D14}" type="datetime3">
               <a:rPr lang="en-US" smtClean="0"/>
-              <a:t>17 October 2026</a:t>
+              <a:t>24 October 2026</a:t>
             </a:fld>
             <a:endParaRPr lang="en-US"/>
           </a:p>
@@ -4201,7 +4148,7 @@
           <a:p>
             <a:fld id="{264FFBAA-9A17-4F9A-B1BD-20F0F5B52AB6}" type="datetime3">
               <a:rPr lang="en-US" smtClean="0"/>
-              <a:t>17 October 2026</a:t>
+              <a:t>24 October 2026</a:t>
             </a:fld>
             <a:endParaRPr lang="en-US" dirty="0"/>
           </a:p>
@@ -5037,7 +4984,7 @@
           <a:p>
             <a:fld id="{9FE8A9F4-4DB3-4EF1-A315-68E41BB689F2}" type="datetime3">
               <a:rPr lang="en-US" smtClean="0"/>
-              <a:t>17 October 2026</a:t>
+              <a:t>24 October 2026</a:t>
             </a:fld>
             <a:endParaRPr lang="en-US"/>
           </a:p>
@@ -5281,7 +5228,7 @@
           <a:p>
             <a:fld id="{EB7275DB-6D13-480B-AC77-F5019BDC5287}" type="datetime3">
               <a:rPr lang="en-US" smtClean="0"/>
-              <a:t>17 October 2026</a:t>
+              <a:t>24 October 2026</a:t>
             </a:fld>
             <a:endParaRPr lang="en-US"/>
           </a:p>
@@ -5760,7 +5707,12 @@
             <p:ph idx="1"/>
           </p:nvPr>
         </p:nvSpPr>
-        <p:spPr/>
+        <p:spPr>
+          <a:xfrm>
+            <a:off x="457200" y="1610032"/>
+            <a:ext cx="8229600" cy="4525963"/>
+          </a:xfrm>
+        </p:spPr>
         <p:txBody>
           <a:bodyPr/>
           <a:lstStyle/>

</xml_diff>